<commit_message>
docs: relabel Fig.5 GPU Worker as Ascend nodes for Kunpeng briefing
Autonomously-by: Cursor-Grok:4.6

Co-authored-by: fangyushanghai <fangyushanghai@gmail.com>
</commit_message>
<xml_diff>
--- a/docs/assets/maiui-fig5-slide.pptx
+++ b/docs/assets/maiui-fig5-slide.pptx
@@ -3293,7 +3293,7 @@
                 </a:solidFill>
                 <a:latin typeface="微软雅黑"/>
               </a:rPr>
-              <a:t>② 非截图阶段 · CPU Worker 路数
+              <a:t>② 非截图阶段 · 鲲鹏沙箱路数
 决策期不需要新帧，软渲染仍在出帧，较多占用 CPU，单机并发沙箱密度减少。可优化空间 20%+†</a:t>
             </a:r>
           </a:p>
@@ -3328,7 +3328,7 @@
                 </a:solidFill>
                 <a:latin typeface="微软雅黑"/>
               </a:rPr>
-              <a:t>* 中小模型、单步约 2–3s。† 全程 60→20fps 实验上限，不是按需已兑现。左图为结构草图，胶片可换成 MAI-UI Fig.5 原图并保留 ①②。</a:t>
+              <a:t>* 中小模型、单步约 2–3s。† 全程 60→20fps 实验上限，不是按需已兑现。左图为结构草图：昇腾节点跑模型，鲲鹏节点跑沙箱。论文 Fig.5 写 GPU Worker，口播改称昇腾节点。</a:t>
             </a:r>
           </a:p>
         </p:txBody>

</xml_diff>

<commit_message>
docs: use device-agnostic model/sandbox node labels on Fig.5 slide
Autonomously-by: Cursor-Grok:4.6

Co-authored-by: fangyushanghai <fangyushanghai@gmail.com>
</commit_message>
<xml_diff>
--- a/docs/assets/maiui-fig5-slide.pptx
+++ b/docs/assets/maiui-fig5-slide.pptx
@@ -3293,7 +3293,7 @@
                 </a:solidFill>
                 <a:latin typeface="微软雅黑"/>
               </a:rPr>
-              <a:t>② 非截图阶段 · 鲲鹏沙箱路数
+              <a:t>② 非截图阶段 · 沙箱节点路数
 决策期不需要新帧，软渲染仍在出帧，较多占用 CPU，单机并发沙箱密度减少。可优化空间 20%+†</a:t>
             </a:r>
           </a:p>
@@ -3328,7 +3328,7 @@
                 </a:solidFill>
                 <a:latin typeface="微软雅黑"/>
               </a:rPr>
-              <a:t>* 中小模型、单步约 2–3s。† 全程 60→20fps 实验上限，不是按需已兑现。左图为结构草图：昇腾节点跑模型，鲲鹏节点跑沙箱。论文 Fig.5 写 GPU Worker，口播改称昇腾节点。</a:t>
+              <a:t>* 中小模型、单步约 2–3s。† 全程 60→20fps 实验上限，不是按需已兑现。模型节点 = GPU 或昇腾；沙箱节点 = CPU。论文 Fig.5 的 GPU Worker 按此口播。</a:t>
             </a:r>
           </a:p>
         </p:txBody>

</xml_diff>